<commit_message>
Completar bono de población y clima con fuentes verificables
</commit_message>
<xml_diff>
--- a/Presentacion_ejecutiva_NYC.pptx
+++ b/Presentacion_ejecutiva_NYC.pptx
@@ -17,6 +17,8 @@
     <p:sldId xmlns:r="http://schemas.openxmlformats.org/officeDocument/2006/relationships" id="262" r:id="Ra1ee8bae0c414f99"/>
     <p:sldId xmlns:r="http://schemas.openxmlformats.org/officeDocument/2006/relationships" id="263" r:id="Re9da982b98da4b0c"/>
     <p:sldId xmlns:r="http://schemas.openxmlformats.org/officeDocument/2006/relationships" id="264" r:id="R817313b650234bc2"/>
+    <p:sldId xmlns:ns0="http://schemas.openxmlformats.org/officeDocument/2006/relationships" id="266" ns0:id="rId16"/>
+    <p:sldId xmlns:ns0="http://schemas.openxmlformats.org/officeDocument/2006/relationships" id="267" ns0:id="rId17"/>
     <p:sldId xmlns:r="http://schemas.openxmlformats.org/officeDocument/2006/relationships" id="265" r:id="Rae697a558d414e68"/>
   </p:sldIdLst>
   <p:sldSz cx="12192000" cy="6858000"/>
@@ -521,7 +523,7 @@
           <a:lstStyle xmlns:a="http://schemas.openxmlformats.org/drawingml/2006/main"/>
           <a:p xmlns:a="http://schemas.openxmlformats.org/drawingml/2006/main">
             <a:r>
-              <a:t>1:30. Cierre y preguntas. Total aproximado: 15 minutos.</a:t>
+              <a:t>1:00. Cierre y preguntas. Total aproximado: 15 minutos.</a:t>
             </a:r>
           </a:p>
         </p:txBody>
@@ -547,6 +549,146 @@
   </p:cSld>
   <p:clrMapOvr>
     <a:masterClrMapping xmlns:a="http://schemas.openxmlformats.org/drawingml/2006/main"/>
+  </p:clrMapOvr>
+</p:notes>
+</file>
+
+<file path=ppt/notesSlides/notesSlide11.xml><?xml version="1.0" encoding="utf-8"?>
+<p:notes xmlns:a="http://schemas.openxmlformats.org/drawingml/2006/main" xmlns:p="http://schemas.openxmlformats.org/presentationml/2006/main" xmlns:r="http://schemas.openxmlformats.org/officeDocument/2006/relationships">
+  <p:cSld>
+    <p:spTree>
+      <p:nvGrpSpPr>
+        <p:cNvPr id="1" name=""/>
+        <p:cNvGrpSpPr/>
+        <p:nvPr/>
+      </p:nvGrpSpPr>
+      <p:grpSpPr>
+        <a:xfrm>
+          <a:off x="0" y="0"/>
+          <a:ext cx="0" cy="0"/>
+          <a:chOff x="0" y="0"/>
+          <a:chExt cx="0" cy="0"/>
+        </a:xfrm>
+      </p:grpSpPr>
+      <p:sp>
+        <p:nvSpPr>
+          <p:cNvPr id="2" name="Slide Image Placeholder 1"/>
+          <p:cNvSpPr>
+            <a:spLocks noGrp="1"/>
+          </p:cNvSpPr>
+          <p:nvPr>
+            <p:ph type="sldImg" idx="2"/>
+          </p:nvPr>
+        </p:nvSpPr>
+        <p:spPr/>
+      </p:sp>
+      <p:sp>
+        <p:nvSpPr>
+          <p:cNvPr id="3" name="Notes Placeholder 2"/>
+          <p:cNvSpPr>
+            <a:spLocks noGrp="1"/>
+          </p:cNvSpPr>
+          <p:nvPr>
+            <p:ph type="body" idx="3" sz="quarter"/>
+          </p:nvPr>
+        </p:nvSpPr>
+        <p:spPr/>
+        <p:txBody>
+          <a:bodyPr/>
+          <a:lstStyle/>
+          <a:p>
+            <a:r>
+              <a:t>0:45. La dirección antigua del PDF ya no existe. El script inspeccionó el HTML de la página actual y extrajo la tabla pública de Tableau. Los cinco boroughs se identifican por condado. No usar estas cifras sin ajuste como denominador de arrestos de 2026.</a:t>
+            </a:r>
+          </a:p>
+        </p:txBody>
+      </p:sp>
+      <p:sp>
+        <p:nvSpPr>
+          <p:cNvPr id="4" name="Slide Number Placeholder 3"/>
+          <p:cNvSpPr>
+            <a:spLocks noGrp="1"/>
+          </p:cNvSpPr>
+          <p:nvPr>
+            <p:ph type="sldNum" idx="5" sz="quarter"/>
+          </p:nvPr>
+        </p:nvSpPr>
+        <p:spPr/>
+      </p:sp>
+    </p:spTree>
+  </p:cSld>
+  <p:clrMapOvr>
+    <a:masterClrMapping/>
+  </p:clrMapOvr>
+</p:notes>
+</file>
+
+<file path=ppt/notesSlides/notesSlide12.xml><?xml version="1.0" encoding="utf-8"?>
+<p:notes xmlns:a="http://schemas.openxmlformats.org/drawingml/2006/main" xmlns:p="http://schemas.openxmlformats.org/presentationml/2006/main" xmlns:r="http://schemas.openxmlformats.org/officeDocument/2006/relationships">
+  <p:cSld>
+    <p:spTree>
+      <p:nvGrpSpPr>
+        <p:cNvPr id="1" name=""/>
+        <p:cNvGrpSpPr/>
+        <p:nvPr/>
+      </p:nvGrpSpPr>
+      <p:grpSpPr>
+        <a:xfrm>
+          <a:off x="0" y="0"/>
+          <a:ext cx="0" cy="0"/>
+          <a:chOff x="0" y="0"/>
+          <a:chExt cx="0" cy="0"/>
+        </a:xfrm>
+      </p:grpSpPr>
+      <p:sp>
+        <p:nvSpPr>
+          <p:cNvPr id="2" name="Slide Image Placeholder 1"/>
+          <p:cNvSpPr>
+            <a:spLocks noGrp="1"/>
+          </p:cNvSpPr>
+          <p:nvPr>
+            <p:ph type="sldImg" idx="2"/>
+          </p:nvPr>
+        </p:nvSpPr>
+        <p:spPr/>
+      </p:sp>
+      <p:sp>
+        <p:nvSpPr>
+          <p:cNvPr id="3" name="Notes Placeholder 2"/>
+          <p:cNvSpPr>
+            <a:spLocks noGrp="1"/>
+          </p:cNvSpPr>
+          <p:nvPr>
+            <p:ph type="body" idx="3" sz="quarter"/>
+          </p:nvPr>
+        </p:nvSpPr>
+        <p:spPr/>
+        <p:txBody>
+          <a:bodyPr/>
+          <a:lstStyle/>
+          <a:p>
+            <a:r>
+              <a:t>0:45. Open-Meteo aporta una serie real de reanálisis para las coordenadas de Nueva York. El gráfico muestra promedios mensuales. No se ha ejecutado OpenWeatherMap porque no hay clave configurada; el código aceptará OPENWEATHER_API_KEY. Esta serie no demuestra causalidad sobre siniestros.</a:t>
+            </a:r>
+          </a:p>
+        </p:txBody>
+      </p:sp>
+      <p:sp>
+        <p:nvSpPr>
+          <p:cNvPr id="4" name="Slide Number Placeholder 3"/>
+          <p:cNvSpPr>
+            <a:spLocks noGrp="1"/>
+          </p:cNvSpPr>
+          <p:nvPr>
+            <p:ph type="sldNum" idx="5" sz="quarter"/>
+          </p:nvPr>
+        </p:nvSpPr>
+        <p:spPr/>
+      </p:sp>
+    </p:spTree>
+  </p:cSld>
+  <p:clrMapOvr>
+    <a:masterClrMapping/>
   </p:clrMapOvr>
 </p:notes>
 </file>
@@ -731,7 +873,7 @@
           <a:lstStyle xmlns:a="http://schemas.openxmlformats.org/drawingml/2006/main"/>
           <a:p xmlns:a="http://schemas.openxmlformats.org/drawingml/2006/main">
             <a:r>
-              <a:t>1:45. Fuentes oficiales: https://data.cityofnewyork.us/resource/uip8-fykc.json ; https://data.cityofnewyork.us/resource/cts7-vksw.json ; https://data.cityofnewyork.us/resource/bm4k-52h4.json ; https://data.cityofnewyork.us/resource/f9bf-2cp4.json ; https://reports.collegeboard.org/media/pdf/2024-new-york-sat-suite-of-assessments-annual-report-ADA.pdf</a:t>
+              <a:t>1:30. Fuentes oficiales: https://data.cityofnewyork.us/resource/uip8-fykc.json ; https://data.cityofnewyork.us/resource/cts7-vksw.json ; https://data.cityofnewyork.us/resource/bm4k-52h4.json ; https://data.cityofnewyork.us/resource/f9bf-2cp4.json ; https://reports.collegeboard.org/media/pdf/2024-new-york-sat-suite-of-assessments-annual-report-ADA.pdf</a:t>
             </a:r>
           </a:p>
         </p:txBody>
@@ -941,7 +1083,7 @@
           <a:lstStyle xmlns:a="http://schemas.openxmlformats.org/drawingml/2006/main"/>
           <a:p xmlns:a="http://schemas.openxmlformats.org/drawingml/2006/main">
             <a:r>
-              <a:t>1:45. College Board advierte por participación y uso de puntajes. Referencia: https://reports.collegeboard.org/media/pdf/2024-new-york-sat-suite-of-assessments-annual-report-ADA.pdf</a:t>
+              <a:t>1:30. College Board advierte por participación y uso de puntajes. Referencia: https://reports.collegeboard.org/media/pdf/2024-new-york-sat-suite-of-assessments-annual-report-ADA.pdf</a:t>
             </a:r>
           </a:p>
         </p:txBody>
@@ -1081,7 +1223,7 @@
           <a:lstStyle xmlns:a="http://schemas.openxmlformats.org/drawingml/2006/main"/>
           <a:p xmlns:a="http://schemas.openxmlformats.org/drawingml/2006/main">
             <a:r>
-              <a:t>1:45. Las ocho preguntas completas aparecen en el informe. Incluyen concentración y tasas de arrestos, lesiones graves y riesgo vial, contexto ponderado de pobreza y efecto de pilotos. Son acciones propuestas, no efectos probados.</a:t>
+              <a:t>1:15. Las ocho preguntas completas aparecen en el informe. Incluyen concentración y tasas de arrestos, lesiones graves y riesgo vial, contexto ponderado de pobreza y efecto de pilotos. Son acciones propuestas, no efectos probados.</a:t>
             </a:r>
           </a:p>
         </p:txBody>
@@ -1866,25 +2008,15 @@
           <a:lstStyle xmlns:a="http://schemas.openxmlformats.org/drawingml/2006/main"/>
           <a:p xmlns:a="http://schemas.openxmlformats.org/drawingml/2006/main">
             <a:pPr>
-              <a:defRPr sz="1200" b="0">
+              <a:defRPr sz="1200">
                 <a:solidFill>
                   <a:srgbClr val="627585"/>
                 </a:solidFill>
                 <a:latin typeface="Aptos"/>
-                <a:ea typeface="Aptos"/>
-                <a:cs typeface="Aptos"/>
-              </a:defRPr>
-            </a:pPr>
-            <a:r>
-              <a:rPr sz="1200" b="0">
-                <a:solidFill>
-                  <a:srgbClr val="627585"/>
-                </a:solidFill>
-                <a:latin typeface="Aptos"/>
-                <a:ea typeface="Aptos"/>
-                <a:cs typeface="Aptos"/>
-              </a:rPr>
-              <a:t>01 / 10</a:t>
+              </a:defRPr>
+            </a:pPr>
+            <a:r>
+              <a:t>01 / 12</a:t>
             </a:r>
           </a:p>
         </p:txBody>
@@ -1900,6 +2032,538 @@
 </file>
 
 <file path=ppt/slides/slide10.xml><?xml version="1.0" encoding="utf-8"?>
+<p:sld xmlns:a="http://schemas.openxmlformats.org/drawingml/2006/main" xmlns:p="http://schemas.openxmlformats.org/presentationml/2006/main" xmlns:r="http://schemas.openxmlformats.org/officeDocument/2006/relationships">
+  <p:cSld>
+    <p:bg>
+      <p:bgPr>
+        <a:solidFill>
+          <a:srgbClr val="FFFFFF"/>
+        </a:solidFill>
+        <a:effectLst/>
+      </p:bgPr>
+    </p:bg>
+    <p:spTree>
+      <p:nvGrpSpPr>
+        <p:cNvPr id="1" name=""/>
+        <p:cNvGrpSpPr/>
+        <p:nvPr/>
+      </p:nvGrpSpPr>
+      <p:grpSpPr/>
+      <p:sp>
+        <p:nvSpPr>
+          <p:cNvPr id="2" name="TextBox 1"/>
+          <p:cNvSpPr txBox="1"/>
+          <p:nvPr/>
+        </p:nvSpPr>
+        <p:spPr>
+          <a:xfrm>
+            <a:off x="685800" y="521207"/>
+            <a:ext cx="10817352" cy="713232"/>
+          </a:xfrm>
+          <a:prstGeom prst="rect">
+            <a:avLst/>
+          </a:prstGeom>
+          <a:noFill/>
+        </p:spPr>
+        <p:txBody>
+          <a:bodyPr wrap="square">
+            <a:spAutoFit/>
+          </a:bodyPr>
+          <a:lstStyle/>
+          <a:p>
+            <a:pPr>
+              <a:defRPr sz="2925" b="1">
+                <a:solidFill>
+                  <a:srgbClr val="162C3B"/>
+                </a:solidFill>
+                <a:latin typeface="Aptos"/>
+              </a:defRPr>
+            </a:pPr>
+            <a:r>
+              <a:t>Bono: población por borough</a:t>
+            </a:r>
+          </a:p>
+        </p:txBody>
+      </p:sp>
+      <p:pic>
+        <p:nvPicPr>
+          <p:cNvPr id="3" name="Picture 2" descr="bono_poblacion_nyc.png"/>
+          <p:cNvPicPr>
+            <a:picLocks noChangeAspect="1"/>
+          </p:cNvPicPr>
+          <p:nvPr/>
+        </p:nvPicPr>
+        <p:blipFill>
+          <a:blip r:embed="rId2"/>
+          <a:stretch>
+            <a:fillRect/>
+          </a:stretch>
+        </p:blipFill>
+        <p:spPr>
+          <a:xfrm>
+            <a:off x="731520" y="1508760"/>
+            <a:ext cx="6720840" cy="3770227"/>
+          </a:xfrm>
+          <a:prstGeom prst="rect">
+            <a:avLst/>
+          </a:prstGeom>
+        </p:spPr>
+      </p:pic>
+      <p:sp>
+        <p:nvSpPr>
+          <p:cNvPr id="4" name="TextBox 3"/>
+          <p:cNvSpPr txBox="1"/>
+          <p:nvPr/>
+        </p:nvSpPr>
+        <p:spPr>
+          <a:xfrm>
+            <a:off x="7726679" y="1691640"/>
+            <a:ext cx="3685032" cy="822960"/>
+          </a:xfrm>
+          <a:prstGeom prst="rect">
+            <a:avLst/>
+          </a:prstGeom>
+          <a:noFill/>
+        </p:spPr>
+        <p:txBody>
+          <a:bodyPr wrap="square">
+            <a:spAutoFit/>
+          </a:bodyPr>
+          <a:lstStyle/>
+          <a:p>
+            <a:pPr>
+              <a:defRPr sz="1800" b="0">
+                <a:solidFill>
+                  <a:srgbClr val="162C3B"/>
+                </a:solidFill>
+                <a:latin typeface="Aptos"/>
+              </a:defRPr>
+            </a:pPr>
+            <a:r>
+              <a:t>Extracción real de 195 filas del tablero oficial actualizado.</a:t>
+            </a:r>
+          </a:p>
+        </p:txBody>
+      </p:sp>
+      <p:sp>
+        <p:nvSpPr>
+          <p:cNvPr id="5" name="TextBox 4"/>
+          <p:cNvSpPr txBox="1"/>
+          <p:nvPr/>
+        </p:nvSpPr>
+        <p:spPr>
+          <a:xfrm>
+            <a:off x="7726679" y="2743200"/>
+            <a:ext cx="3685032" cy="822960"/>
+          </a:xfrm>
+          <a:prstGeom prst="rect">
+            <a:avLst/>
+          </a:prstGeom>
+          <a:noFill/>
+        </p:spPr>
+        <p:txBody>
+          <a:bodyPr wrap="square">
+            <a:spAutoFit/>
+          </a:bodyPr>
+          <a:lstStyle/>
+          <a:p>
+            <a:pPr>
+              <a:defRPr sz="1800" b="0">
+                <a:solidFill>
+                  <a:srgbClr val="162C3B"/>
+                </a:solidFill>
+                <a:latin typeface="Aptos"/>
+              </a:defRPr>
+            </a:pPr>
+            <a:r>
+              <a:t>Promedio anual 2019–2023: Brooklyn 2,66 millones; Staten Island 0,49 millones.</a:t>
+            </a:r>
+          </a:p>
+        </p:txBody>
+      </p:sp>
+      <p:sp>
+        <p:nvSpPr>
+          <p:cNvPr id="6" name="TextBox 5"/>
+          <p:cNvSpPr txBox="1"/>
+          <p:nvPr/>
+        </p:nvSpPr>
+        <p:spPr>
+          <a:xfrm>
+            <a:off x="7726679" y="3794760"/>
+            <a:ext cx="3685032" cy="822960"/>
+          </a:xfrm>
+          <a:prstGeom prst="rect">
+            <a:avLst/>
+          </a:prstGeom>
+          <a:noFill/>
+        </p:spPr>
+        <p:txBody>
+          <a:bodyPr wrap="square">
+            <a:spAutoFit/>
+          </a:bodyPr>
+          <a:lstStyle/>
+          <a:p>
+            <a:pPr>
+              <a:defRPr sz="1800" b="0">
+                <a:solidFill>
+                  <a:srgbClr val="162C3B"/>
+                </a:solidFill>
+                <a:latin typeface="Aptos"/>
+              </a:defRPr>
+            </a:pPr>
+            <a:r>
+              <a:t>Es contexto territorial; las tasas requieren periodos comparables.</a:t>
+            </a:r>
+          </a:p>
+        </p:txBody>
+      </p:sp>
+      <p:sp>
+        <p:nvSpPr>
+          <p:cNvPr id="7" name="TextBox 6"/>
+          <p:cNvSpPr txBox="1"/>
+          <p:nvPr/>
+        </p:nvSpPr>
+        <p:spPr>
+          <a:xfrm>
+            <a:off x="822960" y="5989320"/>
+            <a:ext cx="9966960" cy="502920"/>
+          </a:xfrm>
+          <a:prstGeom prst="rect">
+            <a:avLst/>
+          </a:prstGeom>
+          <a:noFill/>
+        </p:spPr>
+        <p:txBody>
+          <a:bodyPr wrap="square">
+            <a:spAutoFit/>
+          </a:bodyPr>
+          <a:lstStyle/>
+          <a:p>
+            <a:pPr>
+              <a:defRPr sz="1050" b="0">
+                <a:solidFill>
+                  <a:srgbClr val="627585"/>
+                </a:solidFill>
+                <a:latin typeface="Aptos"/>
+              </a:defRPr>
+            </a:pPr>
+            <a:r>
+              <a:t>Fuente: NYS Department of Health, Population Estimates by County and PUMA, 2019–2023.</a:t>
+            </a:r>
+          </a:p>
+        </p:txBody>
+      </p:sp>
+      <p:sp>
+        <p:nvSpPr>
+          <p:cNvPr id="8" name="TextBox 7"/>
+          <p:cNvSpPr txBox="1"/>
+          <p:nvPr/>
+        </p:nvSpPr>
+        <p:spPr>
+          <a:xfrm>
+            <a:off x="10195560" y="6291072"/>
+            <a:ext cx="1371600" cy="283464"/>
+          </a:xfrm>
+          <a:prstGeom prst="rect">
+            <a:avLst/>
+          </a:prstGeom>
+          <a:noFill/>
+        </p:spPr>
+        <p:txBody>
+          <a:bodyPr wrap="square">
+            <a:spAutoFit/>
+          </a:bodyPr>
+          <a:lstStyle/>
+          <a:p>
+            <a:pPr algn="r">
+              <a:defRPr sz="1200" b="0">
+                <a:solidFill>
+                  <a:srgbClr val="627585"/>
+                </a:solidFill>
+                <a:latin typeface="Aptos"/>
+              </a:defRPr>
+            </a:pPr>
+            <a:r>
+              <a:t>10 / 12</a:t>
+            </a:r>
+          </a:p>
+        </p:txBody>
+      </p:sp>
+    </p:spTree>
+  </p:cSld>
+  <p:clrMapOvr>
+    <a:masterClrMapping/>
+  </p:clrMapOvr>
+</p:sld>
+</file>
+
+<file path=ppt/slides/slide11.xml><?xml version="1.0" encoding="utf-8"?>
+<p:sld xmlns:a="http://schemas.openxmlformats.org/drawingml/2006/main" xmlns:p="http://schemas.openxmlformats.org/presentationml/2006/main" xmlns:r="http://schemas.openxmlformats.org/officeDocument/2006/relationships">
+  <p:cSld>
+    <p:bg>
+      <p:bgPr>
+        <a:solidFill>
+          <a:srgbClr val="FFFFFF"/>
+        </a:solidFill>
+        <a:effectLst/>
+      </p:bgPr>
+    </p:bg>
+    <p:spTree>
+      <p:nvGrpSpPr>
+        <p:cNvPr id="1" name=""/>
+        <p:cNvGrpSpPr/>
+        <p:nvPr/>
+      </p:nvGrpSpPr>
+      <p:grpSpPr/>
+      <p:sp>
+        <p:nvSpPr>
+          <p:cNvPr id="2" name="TextBox 1"/>
+          <p:cNvSpPr txBox="1"/>
+          <p:nvPr/>
+        </p:nvSpPr>
+        <p:spPr>
+          <a:xfrm>
+            <a:off x="685800" y="521207"/>
+            <a:ext cx="10817352" cy="713232"/>
+          </a:xfrm>
+          <a:prstGeom prst="rect">
+            <a:avLst/>
+          </a:prstGeom>
+          <a:noFill/>
+        </p:spPr>
+        <p:txBody>
+          <a:bodyPr wrap="square">
+            <a:spAutoFit/>
+          </a:bodyPr>
+          <a:lstStyle/>
+          <a:p>
+            <a:pPr>
+              <a:defRPr sz="2925" b="1">
+                <a:solidFill>
+                  <a:srgbClr val="162C3B"/>
+                </a:solidFill>
+                <a:latin typeface="Aptos"/>
+              </a:defRPr>
+            </a:pPr>
+            <a:r>
+              <a:t>Bono: clima con una API abierta</a:t>
+            </a:r>
+          </a:p>
+        </p:txBody>
+      </p:sp>
+      <p:pic>
+        <p:nvPicPr>
+          <p:cNvPr id="3" name="Picture 2" descr="bono_clima_mensual.png"/>
+          <p:cNvPicPr>
+            <a:picLocks noChangeAspect="1"/>
+          </p:cNvPicPr>
+          <p:nvPr/>
+        </p:nvPicPr>
+        <p:blipFill>
+          <a:blip r:embed="rId2"/>
+          <a:stretch>
+            <a:fillRect/>
+          </a:stretch>
+        </p:blipFill>
+        <p:spPr>
+          <a:xfrm>
+            <a:off x="731520" y="1508760"/>
+            <a:ext cx="6720840" cy="3680460"/>
+          </a:xfrm>
+          <a:prstGeom prst="rect">
+            <a:avLst/>
+          </a:prstGeom>
+        </p:spPr>
+      </p:pic>
+      <p:sp>
+        <p:nvSpPr>
+          <p:cNvPr id="4" name="TextBox 3"/>
+          <p:cNvSpPr txBox="1"/>
+          <p:nvPr/>
+        </p:nvSpPr>
+        <p:spPr>
+          <a:xfrm>
+            <a:off x="7726679" y="1691640"/>
+            <a:ext cx="3685032" cy="822960"/>
+          </a:xfrm>
+          <a:prstGeom prst="rect">
+            <a:avLst/>
+          </a:prstGeom>
+          <a:noFill/>
+        </p:spPr>
+        <p:txBody>
+          <a:bodyPr wrap="square">
+            <a:spAutoFit/>
+          </a:bodyPr>
+          <a:lstStyle/>
+          <a:p>
+            <a:pPr>
+              <a:defRPr sz="1800" b="0">
+                <a:solidFill>
+                  <a:srgbClr val="162C3B"/>
+                </a:solidFill>
+                <a:latin typeface="Aptos"/>
+              </a:defRPr>
+            </a:pPr>
+            <a:r>
+              <a:t>Serie ERA5 de 1 826 días completos, 2021–2025.</a:t>
+            </a:r>
+          </a:p>
+        </p:txBody>
+      </p:sp>
+      <p:sp>
+        <p:nvSpPr>
+          <p:cNvPr id="5" name="TextBox 4"/>
+          <p:cNvSpPr txBox="1"/>
+          <p:nvPr/>
+        </p:nvSpPr>
+        <p:spPr>
+          <a:xfrm>
+            <a:off x="7726679" y="2743200"/>
+            <a:ext cx="3685032" cy="822960"/>
+          </a:xfrm>
+          <a:prstGeom prst="rect">
+            <a:avLst/>
+          </a:prstGeom>
+          <a:noFill/>
+        </p:spPr>
+        <p:txBody>
+          <a:bodyPr wrap="square">
+            <a:spAutoFit/>
+          </a:bodyPr>
+          <a:lstStyle/>
+          <a:p>
+            <a:pPr>
+              <a:defRPr sz="1800" b="0">
+                <a:solidFill>
+                  <a:srgbClr val="162C3B"/>
+                </a:solidFill>
+                <a:latin typeface="Aptos"/>
+              </a:defRPr>
+            </a:pPr>
+            <a:r>
+              <a:t>Julio: 25,79 °C de temperatura media mensual.</a:t>
+            </a:r>
+          </a:p>
+        </p:txBody>
+      </p:sp>
+      <p:sp>
+        <p:nvSpPr>
+          <p:cNvPr id="6" name="TextBox 5"/>
+          <p:cNvSpPr txBox="1"/>
+          <p:nvPr/>
+        </p:nvSpPr>
+        <p:spPr>
+          <a:xfrm>
+            <a:off x="7726679" y="3794760"/>
+            <a:ext cx="3685032" cy="822960"/>
+          </a:xfrm>
+          <a:prstGeom prst="rect">
+            <a:avLst/>
+          </a:prstGeom>
+          <a:noFill/>
+        </p:spPr>
+        <p:txBody>
+          <a:bodyPr wrap="square">
+            <a:spAutoFit/>
+          </a:bodyPr>
+          <a:lstStyle/>
+          <a:p>
+            <a:pPr>
+              <a:defRPr sz="1800" b="0">
+                <a:solidFill>
+                  <a:srgbClr val="162C3B"/>
+                </a:solidFill>
+                <a:latin typeface="Aptos"/>
+              </a:defRPr>
+            </a:pPr>
+            <a:r>
+              <a:t>OpenWeatherMap: consulta preparada, pendiente de clave.</a:t>
+            </a:r>
+          </a:p>
+        </p:txBody>
+      </p:sp>
+      <p:sp>
+        <p:nvSpPr>
+          <p:cNvPr id="7" name="TextBox 6"/>
+          <p:cNvSpPr txBox="1"/>
+          <p:nvPr/>
+        </p:nvSpPr>
+        <p:spPr>
+          <a:xfrm>
+            <a:off x="822960" y="5989320"/>
+            <a:ext cx="9966960" cy="502920"/>
+          </a:xfrm>
+          <a:prstGeom prst="rect">
+            <a:avLst/>
+          </a:prstGeom>
+          <a:noFill/>
+        </p:spPr>
+        <p:txBody>
+          <a:bodyPr wrap="square">
+            <a:spAutoFit/>
+          </a:bodyPr>
+          <a:lstStyle/>
+          <a:p>
+            <a:pPr>
+              <a:defRPr sz="1050" b="0">
+                <a:solidFill>
+                  <a:srgbClr val="627585"/>
+                </a:solidFill>
+                <a:latin typeface="Aptos"/>
+              </a:defRPr>
+            </a:pPr>
+            <a:r>
+              <a:t>Fuente ejecutada: Open-Meteo Historical Weather API, ERA5. OpenWeatherMap requiere clave.</a:t>
+            </a:r>
+          </a:p>
+        </p:txBody>
+      </p:sp>
+      <p:sp>
+        <p:nvSpPr>
+          <p:cNvPr id="8" name="TextBox 7"/>
+          <p:cNvSpPr txBox="1"/>
+          <p:nvPr/>
+        </p:nvSpPr>
+        <p:spPr>
+          <a:xfrm>
+            <a:off x="10195560" y="6291072"/>
+            <a:ext cx="1371600" cy="283464"/>
+          </a:xfrm>
+          <a:prstGeom prst="rect">
+            <a:avLst/>
+          </a:prstGeom>
+          <a:noFill/>
+        </p:spPr>
+        <p:txBody>
+          <a:bodyPr wrap="square">
+            <a:spAutoFit/>
+          </a:bodyPr>
+          <a:lstStyle/>
+          <a:p>
+            <a:pPr algn="r">
+              <a:defRPr sz="1200" b="0">
+                <a:solidFill>
+                  <a:srgbClr val="627585"/>
+                </a:solidFill>
+                <a:latin typeface="Aptos"/>
+              </a:defRPr>
+            </a:pPr>
+            <a:r>
+              <a:t>11 / 12</a:t>
+            </a:r>
+          </a:p>
+        </p:txBody>
+      </p:sp>
+    </p:spTree>
+  </p:cSld>
+  <p:clrMapOvr>
+    <a:masterClrMapping/>
+  </p:clrMapOvr>
+</p:sld>
+</file>
+
+<file path=ppt/slides/slide12.xml><?xml version="1.0" encoding="utf-8"?>
 <p:sld xmlns:p="http://schemas.openxmlformats.org/presentationml/2006/main">
   <p:cSld>
     <p:bg>
@@ -2180,25 +2844,15 @@
           <a:lstStyle xmlns:a="http://schemas.openxmlformats.org/drawingml/2006/main"/>
           <a:p xmlns:a="http://schemas.openxmlformats.org/drawingml/2006/main">
             <a:pPr>
-              <a:defRPr sz="1200" b="0">
+              <a:defRPr sz="1200">
                 <a:solidFill>
                   <a:srgbClr val="627585"/>
                 </a:solidFill>
                 <a:latin typeface="Aptos"/>
-                <a:ea typeface="Aptos"/>
-                <a:cs typeface="Aptos"/>
-              </a:defRPr>
-            </a:pPr>
-            <a:r>
-              <a:rPr sz="1200" b="0">
-                <a:solidFill>
-                  <a:srgbClr val="627585"/>
-                </a:solidFill>
-                <a:latin typeface="Aptos"/>
-                <a:ea typeface="Aptos"/>
-                <a:cs typeface="Aptos"/>
-              </a:rPr>
-              <a:t>10 / 10</a:t>
+              </a:defRPr>
+            </a:pPr>
+            <a:r>
+              <a:t>12 / 12</a:t>
             </a:r>
           </a:p>
         </p:txBody>
@@ -2494,25 +3148,15 @@
           <a:lstStyle xmlns:a="http://schemas.openxmlformats.org/drawingml/2006/main"/>
           <a:p xmlns:a="http://schemas.openxmlformats.org/drawingml/2006/main">
             <a:pPr>
-              <a:defRPr sz="1200" b="0">
+              <a:defRPr sz="1200">
                 <a:solidFill>
                   <a:srgbClr val="627585"/>
                 </a:solidFill>
                 <a:latin typeface="Aptos"/>
-                <a:ea typeface="Aptos"/>
-                <a:cs typeface="Aptos"/>
-              </a:defRPr>
-            </a:pPr>
-            <a:r>
-              <a:rPr sz="1200" b="0">
-                <a:solidFill>
-                  <a:srgbClr val="627585"/>
-                </a:solidFill>
-                <a:latin typeface="Aptos"/>
-                <a:ea typeface="Aptos"/>
-                <a:cs typeface="Aptos"/>
-              </a:rPr>
-              <a:t>02 / 10</a:t>
+              </a:defRPr>
+            </a:pPr>
+            <a:r>
+              <a:t>02 / 12</a:t>
             </a:r>
           </a:p>
         </p:txBody>
@@ -2865,25 +3509,15 @@
           <a:lstStyle xmlns:a="http://schemas.openxmlformats.org/drawingml/2006/main"/>
           <a:p xmlns:a="http://schemas.openxmlformats.org/drawingml/2006/main">
             <a:pPr>
-              <a:defRPr sz="1200" b="0">
+              <a:defRPr sz="1200">
                 <a:solidFill>
                   <a:srgbClr val="627585"/>
                 </a:solidFill>
                 <a:latin typeface="Aptos"/>
-                <a:ea typeface="Aptos"/>
-                <a:cs typeface="Aptos"/>
-              </a:defRPr>
-            </a:pPr>
-            <a:r>
-              <a:rPr sz="1200" b="0">
-                <a:solidFill>
-                  <a:srgbClr val="627585"/>
-                </a:solidFill>
-                <a:latin typeface="Aptos"/>
-                <a:ea typeface="Aptos"/>
-                <a:cs typeface="Aptos"/>
-              </a:rPr>
-              <a:t>03 / 10</a:t>
+              </a:defRPr>
+            </a:pPr>
+            <a:r>
+              <a:t>03 / 12</a:t>
             </a:r>
           </a:p>
         </p:txBody>
@@ -3236,25 +3870,15 @@
           <a:lstStyle xmlns:a="http://schemas.openxmlformats.org/drawingml/2006/main"/>
           <a:p xmlns:a="http://schemas.openxmlformats.org/drawingml/2006/main">
             <a:pPr>
-              <a:defRPr sz="1200" b="0">
+              <a:defRPr sz="1200">
                 <a:solidFill>
                   <a:srgbClr val="627585"/>
                 </a:solidFill>
                 <a:latin typeface="Aptos"/>
-                <a:ea typeface="Aptos"/>
-                <a:cs typeface="Aptos"/>
-              </a:defRPr>
-            </a:pPr>
-            <a:r>
-              <a:rPr sz="1200" b="0">
-                <a:solidFill>
-                  <a:srgbClr val="627585"/>
-                </a:solidFill>
-                <a:latin typeface="Aptos"/>
-                <a:ea typeface="Aptos"/>
-                <a:cs typeface="Aptos"/>
-              </a:rPr>
-              <a:t>04 / 10</a:t>
+              </a:defRPr>
+            </a:pPr>
+            <a:r>
+              <a:t>04 / 12</a:t>
             </a:r>
           </a:p>
         </p:txBody>
@@ -3607,25 +4231,15 @@
           <a:lstStyle xmlns:a="http://schemas.openxmlformats.org/drawingml/2006/main"/>
           <a:p xmlns:a="http://schemas.openxmlformats.org/drawingml/2006/main">
             <a:pPr>
-              <a:defRPr sz="1200" b="0">
+              <a:defRPr sz="1200">
                 <a:solidFill>
                   <a:srgbClr val="627585"/>
                 </a:solidFill>
                 <a:latin typeface="Aptos"/>
-                <a:ea typeface="Aptos"/>
-                <a:cs typeface="Aptos"/>
-              </a:defRPr>
-            </a:pPr>
-            <a:r>
-              <a:rPr sz="1200" b="0">
-                <a:solidFill>
-                  <a:srgbClr val="627585"/>
-                </a:solidFill>
-                <a:latin typeface="Aptos"/>
-                <a:ea typeface="Aptos"/>
-                <a:cs typeface="Aptos"/>
-              </a:rPr>
-              <a:t>05 / 10</a:t>
+              </a:defRPr>
+            </a:pPr>
+            <a:r>
+              <a:t>05 / 12</a:t>
             </a:r>
           </a:p>
         </p:txBody>
@@ -3978,25 +4592,15 @@
           <a:lstStyle xmlns:a="http://schemas.openxmlformats.org/drawingml/2006/main"/>
           <a:p xmlns:a="http://schemas.openxmlformats.org/drawingml/2006/main">
             <a:pPr>
-              <a:defRPr sz="1200" b="0">
+              <a:defRPr sz="1200">
                 <a:solidFill>
                   <a:srgbClr val="627585"/>
                 </a:solidFill>
                 <a:latin typeface="Aptos"/>
-                <a:ea typeface="Aptos"/>
-                <a:cs typeface="Aptos"/>
-              </a:defRPr>
-            </a:pPr>
-            <a:r>
-              <a:rPr sz="1200" b="0">
-                <a:solidFill>
-                  <a:srgbClr val="627585"/>
-                </a:solidFill>
-                <a:latin typeface="Aptos"/>
-                <a:ea typeface="Aptos"/>
-                <a:cs typeface="Aptos"/>
-              </a:rPr>
-              <a:t>06 / 10</a:t>
+              </a:defRPr>
+            </a:pPr>
+            <a:r>
+              <a:t>06 / 12</a:t>
             </a:r>
           </a:p>
         </p:txBody>
@@ -4349,25 +4953,15 @@
           <a:lstStyle xmlns:a="http://schemas.openxmlformats.org/drawingml/2006/main"/>
           <a:p xmlns:a="http://schemas.openxmlformats.org/drawingml/2006/main">
             <a:pPr>
-              <a:defRPr sz="1200" b="0">
+              <a:defRPr sz="1200">
                 <a:solidFill>
                   <a:srgbClr val="627585"/>
                 </a:solidFill>
                 <a:latin typeface="Aptos"/>
-                <a:ea typeface="Aptos"/>
-                <a:cs typeface="Aptos"/>
-              </a:defRPr>
-            </a:pPr>
-            <a:r>
-              <a:rPr sz="1200" b="0">
-                <a:solidFill>
-                  <a:srgbClr val="627585"/>
-                </a:solidFill>
-                <a:latin typeface="Aptos"/>
-                <a:ea typeface="Aptos"/>
-                <a:cs typeface="Aptos"/>
-              </a:rPr>
-              <a:t>07 / 10</a:t>
+              </a:defRPr>
+            </a:pPr>
+            <a:r>
+              <a:t>07 / 12</a:t>
             </a:r>
           </a:p>
         </p:txBody>
@@ -4720,25 +5314,15 @@
           <a:lstStyle xmlns:a="http://schemas.openxmlformats.org/drawingml/2006/main"/>
           <a:p xmlns:a="http://schemas.openxmlformats.org/drawingml/2006/main">
             <a:pPr>
-              <a:defRPr sz="1200" b="0">
+              <a:defRPr sz="1200">
                 <a:solidFill>
                   <a:srgbClr val="627585"/>
                 </a:solidFill>
                 <a:latin typeface="Aptos"/>
-                <a:ea typeface="Aptos"/>
-                <a:cs typeface="Aptos"/>
-              </a:defRPr>
-            </a:pPr>
-            <a:r>
-              <a:rPr sz="1200" b="0">
-                <a:solidFill>
-                  <a:srgbClr val="627585"/>
-                </a:solidFill>
-                <a:latin typeface="Aptos"/>
-                <a:ea typeface="Aptos"/>
-                <a:cs typeface="Aptos"/>
-              </a:rPr>
-              <a:t>08 / 10</a:t>
+              </a:defRPr>
+            </a:pPr>
+            <a:r>
+              <a:t>08 / 12</a:t>
             </a:r>
           </a:p>
         </p:txBody>
@@ -5091,25 +5675,15 @@
           <a:lstStyle xmlns:a="http://schemas.openxmlformats.org/drawingml/2006/main"/>
           <a:p xmlns:a="http://schemas.openxmlformats.org/drawingml/2006/main">
             <a:pPr>
-              <a:defRPr sz="1200" b="0">
+              <a:defRPr sz="1200">
                 <a:solidFill>
                   <a:srgbClr val="627585"/>
                 </a:solidFill>
                 <a:latin typeface="Aptos"/>
-                <a:ea typeface="Aptos"/>
-                <a:cs typeface="Aptos"/>
-              </a:defRPr>
-            </a:pPr>
-            <a:r>
-              <a:rPr sz="1200" b="0">
-                <a:solidFill>
-                  <a:srgbClr val="627585"/>
-                </a:solidFill>
-                <a:latin typeface="Aptos"/>
-                <a:ea typeface="Aptos"/>
-                <a:cs typeface="Aptos"/>
-              </a:rPr>
-              <a:t>09 / 10</a:t>
+              </a:defRPr>
+            </a:pPr>
+            <a:r>
+              <a:t>09 / 12</a:t>
             </a:r>
           </a:p>
         </p:txBody>

</xml_diff>